<commit_message>
docs: an inverse direction is a query, not a stored backlink
Records the OSLC link guidance behind dropping oslc:inversePropertyDefinition:
a link assertion is stored once as <x> <forwardURI> <y>, and the reverse is
found by swapping subject and object on that same forward predicate rather
than by also storing <y> <inverseURI> <x>.

This is not abstract. The ASPICE catalog relies on it: SWE.1's inbound rating
criteria are stored only on the criteria, and Resource Navigator renders them
by index query under the shape's oslc:inversePropertyLabel. Storing the
backlink as well would have put the same fact in two places with nothing
keeping them consistent.

Also updates the AAKI overview presentation (binary, not reviewable in this
diff).

Co-Authored-By: Claude Opus 5 (1M context) <noreply@anthropic.com>
</commit_message>
<xml_diff>
--- a/docs/AAKI-Overview-Presentation.pptx
+++ b/docs/AAKI-Overview-Presentation.pptx
@@ -320,7 +320,7 @@
           <a:p>
             <a:fld id="{241EB5C9-1307-BA42-ABA2-0BC069CD8E7F}" type="datetimeFigureOut">
               <a:rPr lang="en-US" smtClean="0"/>
-              <a:t>7/14/26</a:t>
+              <a:t>8/10/26</a:t>
             </a:fld>
             <a:endParaRPr lang="en-US"/>
           </a:p>
@@ -488,7 +488,7 @@
           <a:p>
             <a:fld id="{241EB5C9-1307-BA42-ABA2-0BC069CD8E7F}" type="datetimeFigureOut">
               <a:rPr lang="en-US" smtClean="0"/>
-              <a:t>7/14/26</a:t>
+              <a:t>8/10/26</a:t>
             </a:fld>
             <a:endParaRPr lang="en-US"/>
           </a:p>
@@ -666,7 +666,7 @@
           <a:p>
             <a:fld id="{241EB5C9-1307-BA42-ABA2-0BC069CD8E7F}" type="datetimeFigureOut">
               <a:rPr lang="en-US" smtClean="0"/>
-              <a:t>7/14/26</a:t>
+              <a:t>8/10/26</a:t>
             </a:fld>
             <a:endParaRPr lang="en-US"/>
           </a:p>
@@ -834,7 +834,7 @@
           <a:p>
             <a:fld id="{241EB5C9-1307-BA42-ABA2-0BC069CD8E7F}" type="datetimeFigureOut">
               <a:rPr lang="en-US" smtClean="0"/>
-              <a:t>7/14/26</a:t>
+              <a:t>8/10/26</a:t>
             </a:fld>
             <a:endParaRPr lang="en-US"/>
           </a:p>
@@ -1079,7 +1079,7 @@
           <a:p>
             <a:fld id="{241EB5C9-1307-BA42-ABA2-0BC069CD8E7F}" type="datetimeFigureOut">
               <a:rPr lang="en-US" smtClean="0"/>
-              <a:t>7/14/26</a:t>
+              <a:t>8/10/26</a:t>
             </a:fld>
             <a:endParaRPr lang="en-US"/>
           </a:p>
@@ -1364,7 +1364,7 @@
           <a:p>
             <a:fld id="{241EB5C9-1307-BA42-ABA2-0BC069CD8E7F}" type="datetimeFigureOut">
               <a:rPr lang="en-US" smtClean="0"/>
-              <a:t>7/14/26</a:t>
+              <a:t>8/10/26</a:t>
             </a:fld>
             <a:endParaRPr lang="en-US"/>
           </a:p>
@@ -1783,7 +1783,7 @@
           <a:p>
             <a:fld id="{241EB5C9-1307-BA42-ABA2-0BC069CD8E7F}" type="datetimeFigureOut">
               <a:rPr lang="en-US" smtClean="0"/>
-              <a:t>7/14/26</a:t>
+              <a:t>8/10/26</a:t>
             </a:fld>
             <a:endParaRPr lang="en-US"/>
           </a:p>
@@ -1900,7 +1900,7 @@
           <a:p>
             <a:fld id="{241EB5C9-1307-BA42-ABA2-0BC069CD8E7F}" type="datetimeFigureOut">
               <a:rPr lang="en-US" smtClean="0"/>
-              <a:t>7/14/26</a:t>
+              <a:t>8/10/26</a:t>
             </a:fld>
             <a:endParaRPr lang="en-US"/>
           </a:p>
@@ -1995,7 +1995,7 @@
           <a:p>
             <a:fld id="{241EB5C9-1307-BA42-ABA2-0BC069CD8E7F}" type="datetimeFigureOut">
               <a:rPr lang="en-US" smtClean="0"/>
-              <a:t>7/14/26</a:t>
+              <a:t>8/10/26</a:t>
             </a:fld>
             <a:endParaRPr lang="en-US"/>
           </a:p>
@@ -2270,7 +2270,7 @@
           <a:p>
             <a:fld id="{241EB5C9-1307-BA42-ABA2-0BC069CD8E7F}" type="datetimeFigureOut">
               <a:rPr lang="en-US" smtClean="0"/>
-              <a:t>7/14/26</a:t>
+              <a:t>8/10/26</a:t>
             </a:fld>
             <a:endParaRPr lang="en-US"/>
           </a:p>
@@ -2522,7 +2522,7 @@
           <a:p>
             <a:fld id="{241EB5C9-1307-BA42-ABA2-0BC069CD8E7F}" type="datetimeFigureOut">
               <a:rPr lang="en-US" smtClean="0"/>
-              <a:t>7/14/26</a:t>
+              <a:t>8/10/26</a:t>
             </a:fld>
             <a:endParaRPr lang="en-US"/>
           </a:p>
@@ -2733,7 +2733,7 @@
           <a:p>
             <a:fld id="{241EB5C9-1307-BA42-ABA2-0BC069CD8E7F}" type="datetimeFigureOut">
               <a:rPr lang="en-US" smtClean="0"/>
-              <a:t>7/14/26</a:t>
+              <a:t>8/10/26</a:t>
             </a:fld>
             <a:endParaRPr lang="en-US"/>
           </a:p>
@@ -3127,6 +3127,7 @@
               <a:buNone/>
             </a:pPr>
             <a:r>
+              <a:rPr dirty="0"/>
               <a:t>AI Assisted Knowledge Integration</a:t>
             </a:r>
           </a:p>
@@ -3389,7 +3390,15 @@
           <a:p>
             <a:r>
               <a:rPr dirty="0"/>
-              <a:t>Natural-language questions. Cross-domain queries. “What-if” analyses. Gap and coverage detection </a:t>
+              <a:t>Natural-language questions. Cross-domain queries. “What-if” analyses. </a:t>
+            </a:r>
+            <a:r>
+              <a:rPr lang="en-US" dirty="0"/>
+              <a:t>G</a:t>
+            </a:r>
+            <a:r>
+              <a:rPr dirty="0"/>
+              <a:t>ap and coverage detection </a:t>
             </a:r>
             <a:endParaRPr lang="en-US" dirty="0"/>
           </a:p>
@@ -3472,7 +3481,7 @@
 </file>
 
 <file path=ppt/slides/slide12.xml><?xml version="1.0" encoding="utf-8"?>
-<p:sld xmlns:a="http://schemas.openxmlformats.org/drawingml/2006/main" xmlns:r="http://schemas.openxmlformats.org/officeDocument/2006/relationships" xmlns:p="http://schemas.openxmlformats.org/presentationml/2006/main">
+<p:sld xmlns:a="http://schemas.openxmlformats.org/drawingml/2006/main" xmlns:r="http://schemas.openxmlformats.org/officeDocument/2006/relationships" xmlns:p="http://schemas.openxmlformats.org/presentationml/2006/main" show="0">
   <p:cSld>
     <p:spTree>
       <p:nvGrpSpPr>
@@ -4158,7 +4167,15 @@
             </a:r>
             <a:r>
               <a:rPr dirty="0"/>
-              <a:t> — mechanical operations under pre-authorized policy. </a:t>
+              <a:t> — mechanical operations under pre-authorized policy</a:t>
+            </a:r>
+            <a:r>
+              <a:rPr lang="en-US" dirty="0"/>
+              <a:t> captured in a change set for approval and delivery</a:t>
+            </a:r>
+            <a:r>
+              <a:rPr dirty="0"/>
+              <a:t>. </a:t>
             </a:r>
             <a:r>
               <a:rPr i="1" dirty="0"/>
@@ -4398,70 +4415,104 @@
               <a:buNone/>
             </a:pPr>
             <a:r>
+              <a:rPr dirty="0"/>
               <a:t>One node of a digital thread — the business-motivation domain, a real </a:t>
             </a:r>
             <a:r>
-              <a:rPr i="1"/>
+              <a:rPr i="1" dirty="0"/>
               <a:t>data-gap</a:t>
             </a:r>
             <a:r>
+              <a:rPr dirty="0"/>
               <a:t> fill.</a:t>
             </a:r>
           </a:p>
           <a:p>
             <a:pPr lvl="1"/>
             <a:r>
-              <a:rPr b="1"/>
+              <a:rPr b="1" dirty="0"/>
               <a:t>Define done.</a:t>
             </a:r>
             <a:r>
+              <a:rPr dirty="0"/>
               <a:t> The AI read the OMG Business Motivation Model 1.3 spec → </a:t>
             </a:r>
             <a:r>
-              <a:rPr>
+              <a:rPr dirty="0" err="1">
                 <a:latin typeface="Courier"/>
               </a:rPr>
               <a:t>BMM.ttl</a:t>
             </a:r>
             <a:r>
+              <a:rPr dirty="0"/>
               <a:t> + </a:t>
             </a:r>
             <a:r>
-              <a:rPr>
+              <a:rPr dirty="0">
                 <a:latin typeface="Courier"/>
               </a:rPr>
-              <a:t>BMM-Shapes.ttl</a:t>
-            </a:r>
-            <a:r>
-              <a:t> (25 classes, 49 properties, 14 ResourceShapes). </a:t>
-            </a:r>
-            <a:r>
-              <a:rPr>
+              <a:t>BMM-</a:t>
+            </a:r>
+            <a:r>
+              <a:rPr dirty="0" err="1">
                 <a:latin typeface="Courier"/>
               </a:rPr>
-              <a:t>create-oslc-server</a:t>
-            </a:r>
-            <a:r>
+              <a:t>Shapes.ttl</a:t>
+            </a:r>
+            <a:r>
+              <a:rPr dirty="0"/>
+              <a:t> (25 classes, 49 properties, 14 </a:t>
+            </a:r>
+            <a:r>
+              <a:rPr dirty="0" err="1"/>
+              <a:t>ResourceShapes</a:t>
+            </a:r>
+            <a:r>
+              <a:rPr dirty="0"/>
+              <a:t>). </a:t>
+            </a:r>
+            <a:r>
+              <a:rPr dirty="0">
+                <a:latin typeface="Courier"/>
+              </a:rPr>
+              <a:t>create-</a:t>
+            </a:r>
+            <a:r>
+              <a:rPr dirty="0" err="1">
+                <a:latin typeface="Courier"/>
+              </a:rPr>
+              <a:t>oslc</a:t>
+            </a:r>
+            <a:r>
+              <a:rPr dirty="0">
+                <a:latin typeface="Courier"/>
+              </a:rPr>
+              <a:t>-server</a:t>
+            </a:r>
+            <a:r>
+              <a:rPr dirty="0"/>
               <a:t> assembled a fully operational, AI-ready OSLC server.</a:t>
             </a:r>
           </a:p>
           <a:p>
             <a:pPr lvl="1"/>
             <a:r>
-              <a:rPr b="1"/>
+              <a:rPr b="1" dirty="0"/>
               <a:t>Instantiate runs live.</a:t>
             </a:r>
             <a:r>
+              <a:rPr dirty="0"/>
               <a:t> The AI populates EU-Rent — Vision, Goals, Strategies, Tactics, Influencers, Assessments, Policies — with cross-resource links, in minutes.</a:t>
             </a:r>
           </a:p>
           <a:p>
             <a:pPr lvl="1"/>
             <a:r>
-              <a:rPr b="1"/>
+              <a:rPr b="1" dirty="0"/>
               <a:t>Activate runs live.</a:t>
             </a:r>
             <a:r>
+              <a:rPr dirty="0"/>
               <a:t> “Which goals lack supporting tactics?” “Impact of revising Mission X?” — the AI traverses the OSLC graph and answers.</a:t>
             </a:r>
           </a:p>
@@ -4470,7 +4521,7 @@
               <a:buNone/>
             </a:pPr>
             <a:r>
-              <a:rPr sz="2000"/>
+              <a:rPr sz="2000" dirty="0"/>
               <a:t>Real shapes. Real OSLC server. Real MCP endpoints. Not slide-ware.</a:t>
             </a:r>
           </a:p>
@@ -5156,7 +5207,7 @@
         <p:spPr/>
         <p:txBody>
           <a:bodyPr>
-            <a:normAutofit lnSpcReduction="10000"/>
+            <a:normAutofit fontScale="92500" lnSpcReduction="10000"/>
           </a:bodyPr>
           <a:lstStyle/>
           <a:p>
@@ -5165,7 +5216,15 @@
             </a:pPr>
             <a:r>
               <a:rPr dirty="0"/>
-              <a:t>Seen as nodes and links, three gaps stand in the way</a:t>
+              <a:t>Seen as nodes and links, </a:t>
+            </a:r>
+            <a:r>
+              <a:rPr lang="en-US" dirty="0"/>
+              <a:t>four</a:t>
+            </a:r>
+            <a:r>
+              <a:rPr dirty="0"/>
+              <a:t> gaps stand in the way</a:t>
             </a:r>
             <a:r>
               <a:rPr lang="en-US" dirty="0"/>
@@ -5177,7 +5236,10 @@
             </a:r>
           </a:p>
           <a:p>
-            <a:pPr lvl="1"/>
+            <a:pPr marL="914400" lvl="1" indent="-457200">
+              <a:buFont typeface="+mj-lt"/>
+              <a:buAutoNum type="arabicPeriod"/>
+            </a:pPr>
             <a:r>
               <a:rPr b="1" dirty="0"/>
               <a:t>Missing links between nodes — the connectivity/traceability gap.</a:t>
@@ -5188,7 +5250,10 @@
             </a:r>
           </a:p>
           <a:p>
-            <a:pPr lvl="1"/>
+            <a:pPr marL="914400" lvl="1" indent="-457200">
+              <a:buFont typeface="+mj-lt"/>
+              <a:buAutoNum type="arabicPeriod"/>
+            </a:pPr>
             <a:r>
               <a:rPr b="1" dirty="0"/>
               <a:t>Missing domain nodes — the data gap.</a:t>
@@ -5215,7 +5280,10 @@
             </a:r>
           </a:p>
           <a:p>
-            <a:pPr lvl="1"/>
+            <a:pPr marL="914400" lvl="1" indent="-457200">
+              <a:buFont typeface="+mj-lt"/>
+              <a:buAutoNum type="arabicPeriod"/>
+            </a:pPr>
             <a:r>
               <a:rPr b="1" dirty="0"/>
               <a:t>Ungoverned evolution — the governance &amp; continuous-improvement gap.</a:t>
@@ -5240,6 +5308,22 @@
               <a:rPr dirty="0"/>
               <a:t>, and its conformance lives in episodic audits with no feedback loop. This is where the thread’s value is ultimately realized.</a:t>
             </a:r>
+            <a:endParaRPr lang="en-US" dirty="0"/>
+          </a:p>
+          <a:p>
+            <a:pPr marL="914400" lvl="1" indent="-457200">
+              <a:buFont typeface="+mj-lt"/>
+              <a:buAutoNum type="arabicPeriod"/>
+            </a:pPr>
+            <a:r>
+              <a:rPr lang="en-US" b="1" dirty="0"/>
+              <a:t>Configuration Management </a:t>
+            </a:r>
+            <a:r>
+              <a:rPr lang="en-US" dirty="0"/>
+              <a:t>– managing versions and configurations of all the contributions to the digital thread</a:t>
+            </a:r>
+            <a:endParaRPr dirty="0"/>
           </a:p>
         </p:txBody>
       </p:sp>
@@ -5392,7 +5476,15 @@
             </a:r>
             <a:r>
               <a:rPr dirty="0"/>
-              <a:t> questions and act on governed, trustworthy answers …</a:t>
+              <a:t> questions and act on </a:t>
+            </a:r>
+            <a:r>
+              <a:rPr lang="en-US" dirty="0"/>
+              <a:t>version aware, </a:t>
+            </a:r>
+            <a:r>
+              <a:rPr dirty="0"/>
+              <a:t>governed, trustworthy answers …</a:t>
             </a:r>
           </a:p>
           <a:p>
@@ -5520,7 +5612,7 @@
             <p:ph idx="1"/>
             <p:extLst>
               <p:ext uri="{D42A27DB-BD31-4B8C-83A1-F6EECF244321}">
-                <p14:modId xmlns:p14="http://schemas.microsoft.com/office/powerpoint/2010/main" val="3811291933"/>
+                <p14:modId xmlns:p14="http://schemas.microsoft.com/office/powerpoint/2010/main" val="1203396092"/>
               </p:ext>
             </p:extLst>
           </p:nvPr>
@@ -5800,6 +5892,11 @@
                         <a:rPr sz="1600" dirty="0"/>
                         <a:t> queries; AI drafts findings/ratings, humans own the rating</a:t>
                       </a:r>
+                      <a:r>
+                        <a:rPr lang="en-US" sz="1600" dirty="0"/>
+                        <a:t>, reducing compliance drift</a:t>
+                      </a:r>
+                      <a:endParaRPr sz="1600" dirty="0"/>
                     </a:p>
                   </a:txBody>
                   <a:tcPr/>

</xml_diff>